<commit_message>
[go-slide-creator-ws79] Fix modern-template accent palette for WCAG contrast
Darken all 6 accent colors from light pastels to medium-saturated tones
so they achieve >= 3:1 contrast ratio with white text:

  accent1: F0D4DB → B5485A (deep rose, 5.20:1)
  accent2: DBE7F5 → 4A7AB5 (medium blue, 4.43:1)
  accent3: C9E2D6 → 3A7D5C (forest green, 4.92:1)
  accent4: BABAD6 → 6B5B8D (medium purple, 5.99:1)
  accent5: F0D2BF → C06B3F (terracotta, 3.88:1)
  accent6: F3E49A → 9E8520 (dark gold, 3.60:1)

Co-Authored-By: Claude Opus 4.6 <noreply@anthropic.com>
</commit_message>
<xml_diff>
--- a/templates/modern-template.pptx
+++ b/templates/modern-template.pptx
@@ -2506,22 +2506,22 @@
         <a:srgbClr val="FDF6EA"/>
       </a:lt2>
       <a:accent1>
-        <a:srgbClr val="F0D4DB"/>
+        <a:srgbClr val="B5485A"/>
       </a:accent1>
       <a:accent2>
-        <a:srgbClr val="DBE7F5"/>
+        <a:srgbClr val="4A7AB5"/>
       </a:accent2>
       <a:accent3>
-        <a:srgbClr val="C9E2D6"/>
+        <a:srgbClr val="3A7D5C"/>
       </a:accent3>
       <a:accent4>
-        <a:srgbClr val="BABAD6"/>
+        <a:srgbClr val="6B5B8D"/>
       </a:accent4>
       <a:accent5>
-        <a:srgbClr val="F0D2BF"/>
+        <a:srgbClr val="C06B3F"/>
       </a:accent5>
       <a:accent6>
-        <a:srgbClr val="F3E49A"/>
+        <a:srgbClr val="9E8520"/>
       </a:accent6>
       <a:hlink>
         <a:srgbClr val="7030A0"/>

</xml_diff>

<commit_message>
[go-slide-creator-ovvq] Apply "Section Number" naming to all built-in templates
Rename the upper-right body placeholder to "Section Number" in
forest-green, midnight-blue, and warm-coral Section Divider layouts.
Add a new "Section Number" upper-right placeholder (idx=2) to
modern-template's Section Divider layout.

All 5 templates now expose section_number as a resolvable placeholder_id
via the resolver's semantic tier (case-insensitive name match).

Co-Authored-By: Claude Opus 4.6 <noreply@anthropic.com>
</commit_message>
<xml_diff>
--- a/templates/modern-template.pptx
+++ b/templates/modern-template.pptx
@@ -1029,6 +1029,43 @@
           <a:lstStyle/>
           <a:p>
             <a:endParaRPr lang="en-US"/>
+          </a:p>
+        </p:txBody>
+      </p:sp>
+      <p:sp>
+        <p:nvSpPr>
+          <p:cNvPr id="21" name="Section Number"/>
+          <p:cNvSpPr>
+            <a:spLocks noGrp="1"/>
+          </p:cNvSpPr>
+          <p:nvPr>
+            <p:ph type="body" sz="quarter" idx="2" hasCustomPrompt="1"/>
+          </p:nvPr>
+        </p:nvSpPr>
+        <p:spPr>
+          <a:xfrm>
+            <a:off x="7886700" y="572408"/>
+            <a:ext cx="3182938" cy="3417887"/>
+          </a:xfrm>
+        </p:spPr>
+        <p:txBody>
+          <a:bodyPr/>
+          <a:lstStyle>
+            <a:lvl1pPr marL="11113" indent="-11113">
+              <a:buNone/>
+              <a:defRPr sz="9600">
+                <a:solidFill>
+                  <a:schemeClr val="bg1"/>
+                </a:solidFill>
+              </a:defRPr>
+            </a:lvl1pPr>
+          </a:lstStyle>
+          <a:p>
+            <a:pPr lvl="0"/>
+            <a:r>
+              <a:rPr lang="en-US"/>
+              <a:t>#</a:t>
+            </a:r>
           </a:p>
         </p:txBody>
       </p:sp>

</xml_diff>

<commit_message>
[go-slide-creator-iy2k] Repair modern-template.pptx via OOXML edits
Repurposed slideLayout3.xml (was "Agenda" — structurally a duplicate
One Content) as a Two Content layout (title + body idx 1 + body_2 idx 2,
side-by-side). Added slideLayout6.xml (Blank, no placeholders) and
slideLayout7.xml (Blank + Title, title only). Registered new layouts in
slideMaster1.xml.rels and sldLayoutIdLst; added Content_Types overrides.

All 4 PNGs in ppt/media/ preserved byte-for-byte (SHA-256 verified).
template-check now PASSes with zero FAIL/WARN; validate-template reports
all 7 mandatory layouts. Removed modern-template entries from
conformance_allowlist.json and canonical_placeholders_allowlist.json, and
updated docs/TEMPLATE_SPEC.md Known Exceptions to reflect the repair.
</commit_message>
<xml_diff>
--- a/templates/modern-template.pptx
+++ b/templates/modern-template.pptx
@@ -1099,8 +1099,8 @@
 </file>
 
 <file path=ppt/slideLayouts/slideLayout3.xml><?xml version="1.0" encoding="utf-8"?>
-<p:sldLayout xmlns:a="http://schemas.openxmlformats.org/drawingml/2006/main" xmlns:r="http://schemas.openxmlformats.org/officeDocument/2006/relationships" xmlns:p="http://schemas.openxmlformats.org/presentationml/2006/main" preserve="1">
-  <p:cSld name="Agenda">
+<p:sldLayout xmlns:a="http://schemas.openxmlformats.org/drawingml/2006/main" xmlns:r="http://schemas.openxmlformats.org/officeDocument/2006/relationships" xmlns:p="http://schemas.openxmlformats.org/presentationml/2006/main" type="twoObj" preserve="1">
+  <p:cSld name="Two Content">
     <p:spTree>
       <p:nvGrpSpPr>
         <p:cNvPr id="1" name=""/>
@@ -1115,50 +1115,9 @@
           <a:chExt cx="0" cy="0"/>
         </a:xfrm>
       </p:grpSpPr>
-      <p:pic>
-        <p:nvPicPr>
-          <p:cNvPr id="6" name="Picture 5" descr="A purple circle with black background&#10;&#10;AI-generated content may be incorrect.">
-            <a:extLst>
-              <a:ext uri="{FF2B5EF4-FFF2-40B4-BE49-F238E27FC236}">
-                <a16:creationId xmlns:a16="http://schemas.microsoft.com/office/drawing/2014/main" id="{B90D1FE6-C620-8AEA-8E16-817F8F3005D7}"/>
-              </a:ext>
-            </a:extLst>
-          </p:cNvPr>
-          <p:cNvPicPr>
-            <a:picLocks noChangeAspect="1"/>
-          </p:cNvPicPr>
-          <p:nvPr/>
-        </p:nvPicPr>
-        <p:blipFill>
-          <a:blip r:embed="rId2" cstate="print">
-            <a:extLst>
-              <a:ext uri="{28A0092B-C50C-407E-A947-70E740481C1C}">
-                <a14:useLocalDpi xmlns:a14="http://schemas.microsoft.com/office/drawing/2010/main"/>
-              </a:ext>
-            </a:extLst>
-          </a:blip>
-          <a:srcRect/>
-          <a:stretch/>
-        </p:blipFill>
-        <p:spPr>
-          <a:xfrm>
-            <a:off x="7866083" y="2754085"/>
-            <a:ext cx="4325917" cy="4103915"/>
-          </a:xfrm>
-          <a:prstGeom prst="rect">
-            <a:avLst/>
-          </a:prstGeom>
-        </p:spPr>
-      </p:pic>
       <p:sp>
         <p:nvSpPr>
-          <p:cNvPr id="2" name="title">
-            <a:extLst>
-              <a:ext uri="{FF2B5EF4-FFF2-40B4-BE49-F238E27FC236}">
-                <a16:creationId xmlns:a16="http://schemas.microsoft.com/office/drawing/2014/main" id="{4E4019F8-742E-9EEF-F591-C9666AC32AF1}"/>
-              </a:ext>
-            </a:extLst>
-          </p:cNvPr>
+          <p:cNvPr id="2" name="title"/>
           <p:cNvSpPr>
             <a:spLocks noGrp="1"/>
           </p:cNvSpPr>
@@ -1168,17 +1127,17 @@
         </p:nvSpPr>
         <p:spPr>
           <a:xfrm>
-            <a:off x="612647" y="664108"/>
-            <a:ext cx="8467558" cy="1554480"/>
+            <a:off x="860893" y="907303"/>
+            <a:ext cx="10465073" cy="1132258"/>
           </a:xfrm>
         </p:spPr>
         <p:txBody>
-          <a:bodyPr anchor="b">
-            <a:normAutofit/>
-          </a:bodyPr>
+          <a:bodyPr/>
           <a:lstStyle>
             <a:lvl1pPr>
-              <a:defRPr sz="4400"/>
+              <a:defRPr>
+                <a:latin typeface="+mj-lt"/>
+              </a:defRPr>
             </a:lvl1pPr>
           </a:lstStyle>
           <a:p>
@@ -1186,18 +1145,13 @@
               <a:rPr lang="en-US"/>
               <a:t>Click to edit Master title style</a:t>
             </a:r>
+            <a:endParaRPr lang="en-US" dirty="0"/>
           </a:p>
         </p:txBody>
       </p:sp>
       <p:sp>
         <p:nvSpPr>
-          <p:cNvPr id="7" name="body">
-            <a:extLst>
-              <a:ext uri="{FF2B5EF4-FFF2-40B4-BE49-F238E27FC236}">
-                <a16:creationId xmlns:a16="http://schemas.microsoft.com/office/drawing/2014/main" id="{28C8B19A-6FC1-2B71-0BFB-9274CBF396B9}"/>
-              </a:ext>
-            </a:extLst>
-          </p:cNvPr>
+          <p:cNvPr id="3" name="body"/>
           <p:cNvSpPr>
             <a:spLocks noGrp="1"/>
           </p:cNvSpPr>
@@ -1207,41 +1161,13 @@
         </p:nvSpPr>
         <p:spPr>
           <a:xfrm>
-            <a:off x="612647" y="2333860"/>
-            <a:ext cx="8467558" cy="3689909"/>
+            <a:off x="860893" y="2367643"/>
+            <a:ext cx="5052536" cy="3583053"/>
           </a:xfrm>
         </p:spPr>
         <p:txBody>
-          <a:bodyPr>
-            <a:normAutofit/>
-          </a:bodyPr>
-          <a:lstStyle>
-            <a:lvl1pPr marL="457200" indent="-457200">
-              <a:buFont typeface="+mj-lt"/>
-              <a:buAutoNum type="arabicPeriod"/>
-              <a:defRPr sz="2400"/>
-            </a:lvl1pPr>
-            <a:lvl2pPr marL="685800" indent="-457200">
-              <a:buFont typeface="+mj-lt"/>
-              <a:buAutoNum type="arabicPeriod"/>
-              <a:defRPr sz="2000"/>
-            </a:lvl2pPr>
-            <a:lvl3pPr marL="800100" indent="-342900">
-              <a:buFont typeface="+mj-lt"/>
-              <a:buAutoNum type="arabicPeriod"/>
-              <a:defRPr sz="1800"/>
-            </a:lvl3pPr>
-            <a:lvl4pPr marL="1028700" indent="-342900">
-              <a:buFont typeface="+mj-lt"/>
-              <a:buAutoNum type="arabicPeriod"/>
-              <a:defRPr sz="1600"/>
-            </a:lvl4pPr>
-            <a:lvl5pPr marL="1257300" indent="-342900">
-              <a:buFont typeface="+mj-lt"/>
-              <a:buAutoNum type="arabicPeriod"/>
-              <a:defRPr sz="1400"/>
-            </a:lvl5pPr>
-          </a:lstStyle>
+          <a:bodyPr/>
+          <a:lstStyle/>
           <a:p>
             <a:pPr lvl="0"/>
             <a:r>
@@ -1263,29 +1189,51 @@
               <a:t>Third level</a:t>
             </a:r>
           </a:p>
-          <a:p>
-            <a:pPr lvl="3"/>
+        </p:txBody>
+      </p:sp>
+      <p:sp>
+        <p:nvSpPr>
+          <p:cNvPr id="4" name="body_2"/>
+          <p:cNvSpPr>
+            <a:spLocks noGrp="1"/>
+          </p:cNvSpPr>
+          <p:nvPr>
+            <p:ph type="body" idx="2"/>
+          </p:nvPr>
+        </p:nvSpPr>
+        <p:spPr>
+          <a:xfrm>
+            <a:off x="6273430" y="2367643"/>
+            <a:ext cx="5052536" cy="3583053"/>
+          </a:xfrm>
+        </p:spPr>
+        <p:txBody>
+          <a:bodyPr/>
+          <a:lstStyle/>
+          <a:p>
+            <a:pPr lvl="0"/>
             <a:r>
               <a:rPr lang="en-US"/>
-              <a:t>Fourth level</a:t>
+              <a:t>Click to edit Master text styles</a:t>
             </a:r>
           </a:p>
           <a:p>
-            <a:pPr lvl="4"/>
+            <a:pPr lvl="1"/>
             <a:r>
               <a:rPr lang="en-US"/>
-              <a:t>Fifth level</a:t>
+              <a:t>Second level</a:t>
             </a:r>
-            <a:endParaRPr lang="en-US" dirty="0"/>
+          </a:p>
+          <a:p>
+            <a:pPr lvl="2"/>
+            <a:r>
+              <a:rPr lang="en-US"/>
+              <a:t>Third level</a:t>
+            </a:r>
           </a:p>
         </p:txBody>
       </p:sp>
     </p:spTree>
-    <p:extLst>
-      <p:ext uri="{BB962C8B-B14F-4D97-AF65-F5344CB8AC3E}">
-        <p14:creationId xmlns:p14="http://schemas.microsoft.com/office/powerpoint/2010/main" val="4018192676"/>
-      </p:ext>
-    </p:extLst>
   </p:cSld>
   <p:clrMapOvr>
     <a:masterClrMapping/>
@@ -1647,6 +1595,90 @@
 </p:sldLayout>
 </file>
 
+<file path=ppt/slideLayouts/slideLayout6.xml><?xml version="1.0" encoding="utf-8"?>
+<p:sldLayout xmlns:a="http://schemas.openxmlformats.org/drawingml/2006/main" xmlns:r="http://schemas.openxmlformats.org/officeDocument/2006/relationships" xmlns:p="http://schemas.openxmlformats.org/presentationml/2006/main" type="blank" preserve="1">
+  <p:cSld name="Blank">
+    <p:spTree>
+      <p:nvGrpSpPr>
+        <p:cNvPr id="1" name=""/>
+        <p:cNvGrpSpPr/>
+        <p:nvPr/>
+      </p:nvGrpSpPr>
+      <p:grpSpPr>
+        <a:xfrm>
+          <a:off x="0" y="0"/>
+          <a:ext cx="0" cy="0"/>
+          <a:chOff x="0" y="0"/>
+          <a:chExt cx="0" cy="0"/>
+        </a:xfrm>
+      </p:grpSpPr>
+    </p:spTree>
+  </p:cSld>
+  <p:clrMapOvr>
+    <a:masterClrMapping/>
+  </p:clrMapOvr>
+</p:sldLayout>
+</file>
+
+<file path=ppt/slideLayouts/slideLayout7.xml><?xml version="1.0" encoding="utf-8"?>
+<p:sldLayout xmlns:a="http://schemas.openxmlformats.org/drawingml/2006/main" xmlns:r="http://schemas.openxmlformats.org/officeDocument/2006/relationships" xmlns:p="http://schemas.openxmlformats.org/presentationml/2006/main" type="titleOnly" preserve="1">
+  <p:cSld name="Blank + Title">
+    <p:spTree>
+      <p:nvGrpSpPr>
+        <p:cNvPr id="1" name=""/>
+        <p:cNvGrpSpPr/>
+        <p:nvPr/>
+      </p:nvGrpSpPr>
+      <p:grpSpPr>
+        <a:xfrm>
+          <a:off x="0" y="0"/>
+          <a:ext cx="0" cy="0"/>
+          <a:chOff x="0" y="0"/>
+          <a:chExt cx="0" cy="0"/>
+        </a:xfrm>
+      </p:grpSpPr>
+      <p:sp>
+        <p:nvSpPr>
+          <p:cNvPr id="2" name="title"/>
+          <p:cNvSpPr>
+            <a:spLocks noGrp="1"/>
+          </p:cNvSpPr>
+          <p:nvPr>
+            <p:ph type="title"/>
+          </p:nvPr>
+        </p:nvSpPr>
+        <p:spPr>
+          <a:xfrm>
+            <a:off x="860893" y="907303"/>
+            <a:ext cx="10465073" cy="1132258"/>
+          </a:xfrm>
+        </p:spPr>
+        <p:txBody>
+          <a:bodyPr/>
+          <a:lstStyle>
+            <a:lvl1pPr>
+              <a:defRPr>
+                <a:latin typeface="+mj-lt"/>
+              </a:defRPr>
+            </a:lvl1pPr>
+          </a:lstStyle>
+          <a:p>
+            <a:r>
+              <a:rPr lang="en-US"/>
+              <a:t>Click to edit Master title style</a:t>
+            </a:r>
+            <a:endParaRPr lang="en-US" dirty="0"/>
+          </a:p>
+        </p:txBody>
+      </p:sp>
+    </p:spTree>
+  </p:cSld>
+  <p:clrMapOvr>
+    <a:masterClrMapping/>
+  </p:clrMapOvr>
+</p:sldLayout>
+</file>
+
 <file path=ppt/slideMasters/slideMaster1.xml><?xml version="1.0" encoding="utf-8"?>
 <p:sldMaster xmlns:a="http://schemas.openxmlformats.org/drawingml/2006/main" xmlns:r="http://schemas.openxmlformats.org/officeDocument/2006/relationships" xmlns:p="http://schemas.openxmlformats.org/presentationml/2006/main">
   <p:cSld>
@@ -1930,6 +1962,8 @@
     <p:sldLayoutId id="2147483837" r:id="rId3"/>
     <p:sldLayoutId id="2147483844" r:id="rId4"/>
     <p:sldLayoutId id="2147483879" r:id="rId5"/>
+    <p:sldLayoutId id="2147483900" r:id="rId7"/>
+    <p:sldLayoutId id="2147483901" r:id="rId8"/>
   </p:sldLayoutIdLst>
   <p:hf sldNum="0" hdr="0" ftr="0" dt="0"/>
   <p:txStyles>

</xml_diff>